<commit_message>
update Fri 07/17/2026 13:39:39.68
</commit_message>
<xml_diff>
--- a/GITA/Pre-Acceleration/2026-5h-AI-for-Startups/day2-slides.pptx
+++ b/GITA/Pre-Acceleration/2026-5h-AI-for-Startups/day2-slides.pptx
@@ -14399,7 +14399,7 @@
                 <a:cs typeface="Sylfaen"/>
                 <a:latin typeface="Sylfaen"/>
               </a:rPr>
-              <a:t>0:00 - 1:05: Brand + Photo + Copy + Gamma</a:t>
+              <a:t>0:00 - 0:10: Day 2 Intro &amp; Objectives (10 წთ)</a:t>
             </a:r>
           </a:p>
           <a:p>
@@ -14428,7 +14428,7 @@
                 <a:cs typeface="Sylfaen"/>
                 <a:latin typeface="Sylfaen"/>
               </a:rPr>
-              <a:t>1:05 - 1:35: შესვენება (☕ 30 წთ)</a:t>
+              <a:t>0:10 - 1:00: Block VI: Copywriting &amp; Tone (50 წთ)</a:t>
             </a:r>
           </a:p>
           <a:p>
@@ -14457,7 +14457,7 @@
                 <a:cs typeface="Sylfaen"/>
                 <a:latin typeface="Sylfaen"/>
               </a:rPr>
-              <a:t>1:35 - 1:55: Technical Specification</a:t>
+              <a:t>1:00 - 1:05: ☕ შესვენება (5 წთ)</a:t>
             </a:r>
           </a:p>
           <a:p>
@@ -14486,7 +14486,7 @@
                 <a:cs typeface="Sylfaen"/>
                 <a:latin typeface="Sylfaen"/>
               </a:rPr>
-              <a:t>1:55 - 3:15: Lovable MVP + Supabase + GDPR</a:t>
+              <a:t>1:05 - 1:45: Block VII: Visual Identity &amp; Launch (40 წთ)</a:t>
             </a:r>
           </a:p>
           <a:p>
@@ -14515,7 +14515,7 @@
                 <a:cs typeface="Sylfaen"/>
                 <a:latin typeface="Sylfaen"/>
               </a:rPr>
-              <a:t>3:15 - 4:00: ავტომატიზაცია (Make.com)</a:t>
+              <a:t>1:45 - 2:15: 🥪 მთავარი შესვენება (30 წთ)</a:t>
             </a:r>
           </a:p>
           <a:p>
@@ -14544,7 +14544,123 @@
                 <a:cs typeface="Sylfaen"/>
                 <a:latin typeface="Sylfaen"/>
               </a:rPr>
-              <a:t>4:00 - 5:00: Pitch Deck + VC Mock Grill</a:t>
+              <a:t>2:15 - 3:15: Block VIII: Lovable MVP &amp; Tech Spec (60 წთ)</a:t>
+            </a:r>
+          </a:p>
+          <a:p>
+            <a:pPr algn="l">
+              <a:spcAft>
+                <a:spcPts val="300"/>
+              </a:spcAft>
+            </a:pPr>
+            <a:r>
+              <a:rPr sz="1300" b="1">
+                <a:solidFill>
+                  <a:srgbClr val="3730A3"/>
+                </a:solidFill>
+                <a:ea typeface="Sylfaen"/>
+                <a:cs typeface="Sylfaen"/>
+                <a:latin typeface="Sylfaen"/>
+              </a:rPr>
+              <a:t>▸  </a:t>
+            </a:r>
+            <a:r>
+              <a:rPr sz="1300">
+                <a:solidFill>
+                  <a:srgbClr val="0F172A"/>
+                </a:solidFill>
+                <a:ea typeface="Sylfaen"/>
+                <a:cs typeface="Sylfaen"/>
+                <a:latin typeface="Sylfaen"/>
+              </a:rPr>
+              <a:t>3:15 - 3:20: ☕ შესვენება (5 წთ)</a:t>
+            </a:r>
+          </a:p>
+          <a:p>
+            <a:pPr algn="l">
+              <a:spcAft>
+                <a:spcPts val="300"/>
+              </a:spcAft>
+            </a:pPr>
+            <a:r>
+              <a:rPr sz="1300" b="1">
+                <a:solidFill>
+                  <a:srgbClr val="3730A3"/>
+                </a:solidFill>
+                <a:ea typeface="Sylfaen"/>
+                <a:cs typeface="Sylfaen"/>
+                <a:latin typeface="Sylfaen"/>
+              </a:rPr>
+              <a:t>▸  </a:t>
+            </a:r>
+            <a:r>
+              <a:rPr sz="1300">
+                <a:solidFill>
+                  <a:srgbClr val="0F172A"/>
+                </a:solidFill>
+                <a:ea typeface="Sylfaen"/>
+                <a:cs typeface="Sylfaen"/>
+                <a:latin typeface="Sylfaen"/>
+              </a:rPr>
+              <a:t>3:20 - 4:25: Block IX: Database &amp; Make Automation (65 წთ)</a:t>
+            </a:r>
+          </a:p>
+          <a:p>
+            <a:pPr algn="l">
+              <a:spcAft>
+                <a:spcPts val="300"/>
+              </a:spcAft>
+            </a:pPr>
+            <a:r>
+              <a:rPr sz="1300" b="1">
+                <a:solidFill>
+                  <a:srgbClr val="3730A3"/>
+                </a:solidFill>
+                <a:ea typeface="Sylfaen"/>
+                <a:cs typeface="Sylfaen"/>
+                <a:latin typeface="Sylfaen"/>
+              </a:rPr>
+              <a:t>▸  </a:t>
+            </a:r>
+            <a:r>
+              <a:rPr sz="1300">
+                <a:solidFill>
+                  <a:srgbClr val="0F172A"/>
+                </a:solidFill>
+                <a:ea typeface="Sylfaen"/>
+                <a:cs typeface="Sylfaen"/>
+                <a:latin typeface="Sylfaen"/>
+              </a:rPr>
+              <a:t>4:25 - 4:30: ☕ შესვენება (5 წთ)</a:t>
+            </a:r>
+          </a:p>
+          <a:p>
+            <a:pPr algn="l">
+              <a:spcAft>
+                <a:spcPts val="300"/>
+              </a:spcAft>
+            </a:pPr>
+            <a:r>
+              <a:rPr sz="1300" b="1">
+                <a:solidFill>
+                  <a:srgbClr val="3730A3"/>
+                </a:solidFill>
+                <a:ea typeface="Sylfaen"/>
+                <a:cs typeface="Sylfaen"/>
+                <a:latin typeface="Sylfaen"/>
+              </a:rPr>
+              <a:t>▸  </a:t>
+            </a:r>
+            <a:r>
+              <a:rPr sz="1300">
+                <a:solidFill>
+                  <a:srgbClr val="0F172A"/>
+                </a:solidFill>
+                <a:ea typeface="Sylfaen"/>
+                <a:cs typeface="Sylfaen"/>
+                <a:latin typeface="Sylfaen"/>
+              </a:rPr>
+              <a:t>4:30 - 5:00: Block X: Demo Day &amp; VC Mock Grill (30 წთ)</a:t>
             </a:r>
           </a:p>
         </p:txBody>

</xml_diff>

<commit_message>
update Fri 07/17/2026 21:06:19.33
</commit_message>
<xml_diff>
--- a/GITA/Pre-Acceleration/2026-5h-AI-for-Startups/day2-slides.pptx
+++ b/GITA/Pre-Acceleration/2026-5h-AI-for-Startups/day2-slides.pptx
@@ -32526,7 +32526,7 @@
                 <a:cs typeface="Sylfaen"/>
                 <a:latin typeface="Sylfaen"/>
               </a:rPr>
-              <a:t>Make.com ძირითადი ელემენტები:</a:t>
+              <a:t>📋 ვის რაში გამოგადგებათ (გუნდური ქეისები):</a:t>
             </a:r>
           </a:p>
         </p:txBody>
@@ -32540,7 +32540,7 @@
         <p:spPr>
           <a:xfrm>
             <a:off x="621792" y="2203704"/>
-            <a:ext cx="3771900" cy="2267712"/>
+            <a:ext cx="3771900" cy="2574035"/>
           </a:xfrm>
           <a:prstGeom prst="rect">
             <a:avLst/>
@@ -32578,7 +32578,7 @@
                 <a:cs typeface="Sylfaen"/>
                 <a:latin typeface="Sylfaen"/>
               </a:rPr>
-              <a:t>Scenarios: სრული ავტომატიზაციის სქემები;</a:t>
+              <a:t>🏥 Health &amp; Med (Team 1, 2): შეკვეთების &amp; ჯავშნების ავტომატური SMS/Email შეტყობინებები კლიენტებთან და ექიმებთან.</a:t>
             </a:r>
           </a:p>
           <a:p>
@@ -32607,7 +32607,7 @@
                 <a:cs typeface="Sylfaen"/>
                 <a:latin typeface="Sylfaen"/>
               </a:rPr>
-              <a:t>Modules: აპლიკაციების ბლოკები (მაგ. Gmail, Google Sheets);</a:t>
+              <a:t>🛡️ Travel &amp; Samachablo (Team 9, 10): მომხმარებლისგან მიღებული პანიკის/საფრთხის სიგნალების მყისიერი გაგზავნა Telegram Bot-ში ან Slack-ში.</a:t>
             </a:r>
           </a:p>
           <a:p>
@@ -32636,7 +32636,65 @@
                 <a:cs typeface="Sylfaen"/>
                 <a:latin typeface="Sylfaen"/>
               </a:rPr>
-              <a:t>Filters: პირობები მონაცემთა გასაფილტრად.</a:t>
+              <a:t>⚖️ Legal &amp; Compliance (Team 4, 5): გენერირებული PDF დოკუმენტების ავტომატური ატვირთვა Google Drive-ში და კლიენტთან გაგზავნა.</a:t>
+            </a:r>
+          </a:p>
+          <a:p>
+            <a:pPr algn="l">
+              <a:spcAft>
+                <a:spcPts val="300"/>
+              </a:spcAft>
+            </a:pPr>
+            <a:r>
+              <a:rPr sz="1300" b="1">
+                <a:solidFill>
+                  <a:srgbClr val="3730A3"/>
+                </a:solidFill>
+                <a:ea typeface="Sylfaen"/>
+                <a:cs typeface="Sylfaen"/>
+                <a:latin typeface="Sylfaen"/>
+              </a:rPr>
+              <a:t>▸  </a:t>
+            </a:r>
+            <a:r>
+              <a:rPr sz="1300">
+                <a:solidFill>
+                  <a:srgbClr val="0F172A"/>
+                </a:solidFill>
+                <a:ea typeface="Sylfaen"/>
+                <a:cs typeface="Sylfaen"/>
+                <a:latin typeface="Sylfaen"/>
+              </a:rPr>
+              <a:t>🎒 EdTech (Team 6, 8): Early Adopters-ის ბაზის შევსება Sheets CRM-ში და Welcome-Email-ის გაგზავნა სასწავლო გზამკვლევით.</a:t>
+            </a:r>
+          </a:p>
+          <a:p>
+            <a:pPr algn="l">
+              <a:spcAft>
+                <a:spcPts val="300"/>
+              </a:spcAft>
+            </a:pPr>
+            <a:r>
+              <a:rPr sz="1300" b="1">
+                <a:solidFill>
+                  <a:srgbClr val="3730A3"/>
+                </a:solidFill>
+                <a:ea typeface="Sylfaen"/>
+                <a:cs typeface="Sylfaen"/>
+                <a:latin typeface="Sylfaen"/>
+              </a:rPr>
+              <a:t>▸  </a:t>
+            </a:r>
+            <a:r>
+              <a:rPr sz="1300">
+                <a:solidFill>
+                  <a:srgbClr val="0F172A"/>
+                </a:solidFill>
+                <a:ea typeface="Sylfaen"/>
+                <a:cs typeface="Sylfaen"/>
+                <a:latin typeface="Sylfaen"/>
+              </a:rPr>
+              <a:t>📝 Productivity (Team 7): Smart Diary-ის დავალებების სინქრონიზაცია Google Calendar-სა და Notion-თან.</a:t>
             </a:r>
           </a:p>
         </p:txBody>
@@ -32769,7 +32827,7 @@
                 <a:cs typeface="Sylfaen"/>
                 <a:latin typeface="Sylfaen"/>
               </a:rPr>
-              <a:t>🚀 რატომ Make?</a:t>
+              <a:t>🚀 Make.com-ის უპირატესობა:</a:t>
             </a:r>
           </a:p>
         </p:txBody>
@@ -32810,14 +32868,96 @@
                 <a:cs typeface="Sylfaen"/>
                 <a:latin typeface="Sylfaen"/>
               </a:rPr>
-              <a:t>იგი არის ვიზუალური, მარტივი გამოსაყენებელი და უფასო ვერსიაში გაძლევთ 1000 ოპერაციას თვეში.</a:t>
-            </a:r>
-          </a:p>
-        </p:txBody>
-      </p:sp>
-      <p:sp>
-        <p:nvSpPr>
-          <p:cNvPr id="17" name="Rectangle 16"/>
+              <a:t>ის არის No-Code "ძრავი", რომელიც თქვენს Lovable საიტს აკავშირებს ნებისმიერ გარე სერვისთან (Email, CRM, Sheets, Telegram, Slack) 100% უფასოდ და მარტივად.</a:t>
+            </a:r>
+          </a:p>
+        </p:txBody>
+      </p:sp>
+      <p:sp>
+        <p:nvSpPr>
+          <p:cNvPr id="17" name="TextBox 16"/>
+          <p:cNvSpPr txBox="1"/>
+          <p:nvPr/>
+        </p:nvSpPr>
+        <p:spPr>
+          <a:xfrm>
+            <a:off x="4805172" y="2990088"/>
+            <a:ext cx="3771900" cy="320040"/>
+          </a:xfrm>
+          <a:prstGeom prst="rect">
+            <a:avLst/>
+          </a:prstGeom>
+          <a:noFill/>
+        </p:spPr>
+        <p:txBody>
+          <a:bodyPr wrap="square" anchor="t" lIns="54864" rIns="54864" tIns="54864" bIns="54864">
+            <a:spAutoFit/>
+          </a:bodyPr>
+          <a:lstStyle/>
+          <a:p>
+            <a:pPr>
+              <a:spcAft>
+                <a:spcPts val="400"/>
+              </a:spcAft>
+            </a:pPr>
+            <a:r>
+              <a:rPr sz="1400" b="1" i="0">
+                <a:solidFill>
+                  <a:srgbClr val="0F172A"/>
+                </a:solidFill>
+                <a:ea typeface="Sylfaen"/>
+                <a:cs typeface="Sylfaen"/>
+                <a:latin typeface="Sylfaen"/>
+              </a:rPr>
+              <a:t>📦 ძირითადი ცნებები:</a:t>
+            </a:r>
+          </a:p>
+        </p:txBody>
+      </p:sp>
+      <p:sp>
+        <p:nvSpPr>
+          <p:cNvPr id="18" name="TextBox 17"/>
+          <p:cNvSpPr txBox="1"/>
+          <p:nvPr/>
+        </p:nvSpPr>
+        <p:spPr>
+          <a:xfrm>
+            <a:off x="4805172" y="3383280"/>
+            <a:ext cx="3771900" cy="713232"/>
+          </a:xfrm>
+          <a:prstGeom prst="rect">
+            <a:avLst/>
+          </a:prstGeom>
+          <a:noFill/>
+        </p:spPr>
+        <p:txBody>
+          <a:bodyPr wrap="square" anchor="t" lIns="54864" rIns="54864" tIns="54864" bIns="54864">
+            <a:spAutoFit/>
+          </a:bodyPr>
+          <a:lstStyle/>
+          <a:p>
+            <a:pPr>
+              <a:spcAft>
+                <a:spcPts val="400"/>
+              </a:spcAft>
+            </a:pPr>
+            <a:r>
+              <a:rPr sz="1300" b="0" i="0">
+                <a:solidFill>
+                  <a:srgbClr val="0F172A"/>
+                </a:solidFill>
+                <a:ea typeface="Sylfaen"/>
+                <a:cs typeface="Sylfaen"/>
+                <a:latin typeface="Sylfaen"/>
+              </a:rPr>
+              <a:t>Scenario: ავტომატიზაციის სქემა · Module: აპლიკაციის ბლოკი (მაგ: Gmail) · Webhook: მყისიერი რეაგირების ტრიგერი.</a:t>
+            </a:r>
+          </a:p>
+        </p:txBody>
+      </p:sp>
+      <p:sp>
+        <p:nvSpPr>
+          <p:cNvPr id="19" name="Rectangle 18"/>
           <p:cNvSpPr/>
           <p:nvPr/>
         </p:nvSpPr>
@@ -32861,7 +33001,7 @@
       </p:sp>
       <p:sp>
         <p:nvSpPr>
-          <p:cNvPr id="18" name="TextBox 17"/>
+          <p:cNvPr id="20" name="TextBox 19"/>
           <p:cNvSpPr txBox="1"/>
           <p:nvPr/>
         </p:nvSpPr>

</xml_diff>